<commit_message>
Update format and align it together
</commit_message>
<xml_diff>
--- a/Documents/Figure_3_1.pptx
+++ b/Documents/Figure_3_1.pptx
@@ -114,6 +114,30 @@
 
 <file path=ppt/changesInfos/changesInfo1.xml><?xml version="1.0" encoding="utf-8"?>
 <pc:chgInfo xmlns:a="http://schemas.openxmlformats.org/drawingml/2006/main" xmlns:r="http://schemas.openxmlformats.org/officeDocument/2006/relationships" xmlns:ac="http://schemas.microsoft.com/office/drawing/2013/main/command" xmlns:pc="http://schemas.microsoft.com/office/powerpoint/2013/main/command">
+  <pc:docChgLst>
+    <pc:chgData name="So Sot" userId="88149d4b75946e7d" providerId="LiveId" clId="{8D451779-0052-434E-964A-31F21286BDF9}"/>
+    <pc:docChg chg="modSld">
+      <pc:chgData name="So Sot" userId="88149d4b75946e7d" providerId="LiveId" clId="{8D451779-0052-434E-964A-31F21286BDF9}" dt="2026-03-05T02:30:14.013" v="0" actId="1037"/>
+      <pc:docMkLst>
+        <pc:docMk/>
+      </pc:docMkLst>
+      <pc:sldChg chg="modSp mod">
+        <pc:chgData name="So Sot" userId="88149d4b75946e7d" providerId="LiveId" clId="{8D451779-0052-434E-964A-31F21286BDF9}" dt="2026-03-05T02:30:14.013" v="0" actId="1037"/>
+        <pc:sldMkLst>
+          <pc:docMk/>
+          <pc:sldMk cId="0" sldId="256"/>
+        </pc:sldMkLst>
+        <pc:spChg chg="mod">
+          <ac:chgData name="So Sot" userId="88149d4b75946e7d" providerId="LiveId" clId="{8D451779-0052-434E-964A-31F21286BDF9}" dt="2026-03-05T02:30:14.013" v="0" actId="1037"/>
+          <ac:spMkLst>
+            <pc:docMk/>
+            <pc:sldMk cId="0" sldId="256"/>
+            <ac:spMk id="88" creationId="{00000000-0000-0000-0000-000000000000}"/>
+          </ac:spMkLst>
+        </pc:spChg>
+      </pc:sldChg>
+    </pc:docChg>
+  </pc:docChgLst>
   <pc:docChgLst>
     <pc:chgData name="So Sot" userId="88149d4b75946e7d" providerId="LiveId" clId="{CDED4BEC-08C7-4AF5-9A87-EC294C8A9FD1}"/>
     <pc:docChg chg="modSld">
@@ -1542,9 +1566,9 @@
         <p:grpSpPr>
           <a:xfrm>
             <a:off x="38818" y="182880"/>
-            <a:ext cx="12105733" cy="5779008"/>
+            <a:ext cx="12105732" cy="5779008"/>
             <a:chOff x="38818" y="182880"/>
-            <a:chExt cx="12105733" cy="5779008"/>
+            <a:chExt cx="12105732" cy="5779008"/>
           </a:xfrm>
         </p:grpSpPr>
         <p:sp>
@@ -4286,7 +4310,7 @@
           </p:nvSpPr>
           <p:spPr>
             <a:xfrm>
-              <a:off x="10652759" y="1417320"/>
+              <a:off x="10644133" y="1417320"/>
               <a:ext cx="1491792" cy="3200400"/>
             </a:xfrm>
             <a:prstGeom prst="roundRect">
@@ -5072,7 +5096,7 @@
                     <a:srgbClr val="0D1B3E"/>
                   </a:solidFill>
                 </a:rPr>
-                <a:t>SQL Server 2022   </a:t>
+                <a:t>SQL Server 2025   </a:t>
               </a:r>
               <a:r>
                 <a:rPr lang="en-US" sz="500" dirty="0">

</xml_diff>